<commit_message>
Phase 5H-1: registered results - HAWKES TRACK = NARROW (exploratory, annotation-only)
K1-K3 pass (G4x-G2 +0.145, G4-G3 +0.083 nats/event, above all 38 nulls); K4 fails
(0 reproducible interactions); families SPATIAL and MOTION pass. Full matrix complete
(0 missing/failed/duplicate). Post-hoc: 17.0% exact boundary ties; N-circ +16% /
N-jit -9.3..-9.8% events; K4 statistic shrinkage-inflated. No method contribution.

Exit report, ledger, results notes, Memory, paper section draft, supervisor update,
deck, figures; all headline numbers verified by scripts/phase5h1/verify_results.py.

Co-Authored-By: Claude Opus 5.5 <noreply@anthropic.com>
</commit_message>
<xml_diff>
--- a/results/phase5h1/showcase/phase5h1_supervisor_update.pptx
+++ b/results/phase5h1/showcase/phase5h1_supervisor_update.pptx
@@ -11,6 +11,9 @@
     <p:sldId id="259" r:id="rId5"/>
     <p:sldId id="260" r:id="rId6"/>
     <p:sldId id="261" r:id="rId7"/>
+    <p:sldId id="262" r:id="rId13"/>
+    <p:sldId id="263" r:id="rId14"/>
+    <p:sldId id="264" r:id="rId15"/>
   </p:sldIdLst>
   <p:notesMasterIdLst>
     <p:notesMasterId r:id="rId8"/>
@@ -902,7 +905,7 @@
 </file>
 
 <file path=ppt/notesSlides/notesSlide6.xml><?xml version="1.0" encoding="utf-8"?>
-<p:notes xmlns:a="http://schemas.openxmlformats.org/drawingml/2006/main" xmlns:r="http://schemas.openxmlformats.org/officeDocument/2006/relationships" xmlns:p="http://schemas.openxmlformats.org/presentationml/2006/main">
+<p:notes xmlns:a="http://schemas.openxmlformats.org/drawingml/2006/main" xmlns:p="http://schemas.openxmlformats.org/presentationml/2006/main" xmlns:r="http://schemas.openxmlformats.org/officeDocument/2006/relationships">
   <p:cSld>
     <p:spTree>
       <p:nvGrpSpPr>
@@ -922,10 +925,10 @@
         <p:nvSpPr>
           <p:cNvPr id="2" name="Slide Image Placeholder 1"/>
           <p:cNvSpPr>
-            <a:spLocks noGrp="1" noRot="1" noChangeAspect="1"/>
+            <a:spLocks noGrp="1"/>
           </p:cNvSpPr>
           <p:nvPr>
-            <p:ph type="sldImg"/>
+            <p:ph type="sldImg" idx="2"/>
           </p:nvPr>
         </p:nvSpPr>
         <p:spPr/>
@@ -937,7 +940,7 @@
             <a:spLocks noGrp="1"/>
           </p:cNvSpPr>
           <p:nvPr>
-            <p:ph type="body" idx="1"/>
+            <p:ph type="body" idx="3" sz="quarter"/>
           </p:nvPr>
         </p:nvSpPr>
         <p:spPr/>
@@ -946,10 +949,8 @@
           <a:lstStyle/>
           <a:p>
             <a:r>
-              <a:rPr lang="en-US" dirty="0"/>
-              <a:t>Plan and rules: research/phase5h1_preregistration.md §2 (splits; data-use audit), §6 (nulls), §7 (stability), §8 (hypotheses), §9 (GO / NARROW / STOP). Compute estimate from smoke timing (results/phase5h1/smoke/smoke.json: about 20 s per rung on 200 videos) extrapolated to 5,600 videos, the 4-value ridge grid, 38 null refits of 4 rungs and fold fits — an estimate (30-60 h), not a measurement. Even GO only licenses a confirmatory replication on independent data (candidates: ImageNet-VidVRD or PVSG, which annotate relation start/end times).</a:t>
-            </a:r>
-            <a:endParaRPr lang="en-US" dirty="0"/>
+              <a:t>Source: results/phase5h1/full/tables.md T3, T5; analysis.json. GO needs K1-K4; K4 failed, so the registered rule gives NARROW (K1 + at least one family).</a:t>
+            </a:r>
           </a:p>
         </p:txBody>
       </p:sp>
@@ -960,28 +961,222 @@
             <a:spLocks noGrp="1"/>
           </p:cNvSpPr>
           <p:nvPr>
-            <p:ph type="sldNum" sz="quarter" idx="10"/>
+            <p:ph type="sldNum" idx="5" sz="quarter"/>
           </p:nvPr>
         </p:nvSpPr>
         <p:spPr/>
+      </p:sp>
+    </p:spTree>
+  </p:cSld>
+  <p:clrMapOvr>
+    <a:masterClrMapping/>
+  </p:clrMapOvr>
+</p:notes>
+</file>
+
+<file path=ppt/notesSlides/notesSlide7.xml><?xml version="1.0" encoding="utf-8"?>
+<p:notes xmlns:a="http://schemas.openxmlformats.org/drawingml/2006/main" xmlns:p="http://schemas.openxmlformats.org/presentationml/2006/main" xmlns:r="http://schemas.openxmlformats.org/officeDocument/2006/relationships">
+  <p:cSld>
+    <p:spTree>
+      <p:nvGrpSpPr>
+        <p:cNvPr id="1" name=""/>
+        <p:cNvGrpSpPr/>
+        <p:nvPr/>
+      </p:nvGrpSpPr>
+      <p:grpSpPr>
+        <a:xfrm>
+          <a:off x="0" y="0"/>
+          <a:ext cx="0" cy="0"/>
+          <a:chOff x="0" y="0"/>
+          <a:chExt cx="0" cy="0"/>
+        </a:xfrm>
+      </p:grpSpPr>
+      <p:sp>
+        <p:nvSpPr>
+          <p:cNvPr id="2" name="Slide Image Placeholder 1"/>
+          <p:cNvSpPr>
+            <a:spLocks noGrp="1"/>
+          </p:cNvSpPr>
+          <p:nvPr>
+            <p:ph type="sldImg" idx="2"/>
+          </p:nvPr>
+        </p:nvSpPr>
+        <p:spPr/>
+      </p:sp>
+      <p:sp>
+        <p:nvSpPr>
+          <p:cNvPr id="3" name="Notes Placeholder 2"/>
+          <p:cNvSpPr>
+            <a:spLocks noGrp="1"/>
+          </p:cNvSpPr>
+          <p:nvPr>
+            <p:ph type="body" idx="3" sz="quarter"/>
+          </p:nvPr>
+        </p:nvSpPr>
+        <p:spPr/>
         <p:txBody>
           <a:bodyPr/>
           <a:lstStyle/>
           <a:p>
-            <a:fld id="{F7021451-1387-4CA6-816F-3879F97B5CBC}" type="slidenum">
-              <a:rPr lang="en-US"/>
-              <a:t>6</a:t>
-            </a:fld>
-            <a:endParaRPr lang="en-US"/>
-          </a:p>
-        </p:txBody>
+            <a:r>
+              <a:t>Sources: T4 (nulls), T7 (K4), posthoc_foldnull_cells.json. Whole weight-vector Spearman 0.299 beats every null (max 0.270); no single cell passes.</a:t>
+            </a:r>
+          </a:p>
+        </p:txBody>
+      </p:sp>
+      <p:sp>
+        <p:nvSpPr>
+          <p:cNvPr id="4" name="Slide Number Placeholder 3"/>
+          <p:cNvSpPr>
+            <a:spLocks noGrp="1"/>
+          </p:cNvSpPr>
+          <p:nvPr>
+            <p:ph type="sldNum" idx="5" sz="quarter"/>
+          </p:nvPr>
+        </p:nvSpPr>
+        <p:spPr/>
       </p:sp>
     </p:spTree>
-    <p:extLst>
-      <p:ext uri="{BB962C8B-B14F-4D97-AF65-F5344CB8AC3E}">
-        <p14:creationId xmlns:p14="http://schemas.microsoft.com/office/powerpoint/2010/main" val="1024086991"/>
-      </p:ext>
-    </p:extLst>
+  </p:cSld>
+  <p:clrMapOvr>
+    <a:masterClrMapping/>
+  </p:clrMapOvr>
+</p:notes>
+</file>
+
+<file path=ppt/notesSlides/notesSlide8.xml><?xml version="1.0" encoding="utf-8"?>
+<p:notes xmlns:a="http://schemas.openxmlformats.org/drawingml/2006/main" xmlns:p="http://schemas.openxmlformats.org/presentationml/2006/main" xmlns:r="http://schemas.openxmlformats.org/officeDocument/2006/relationships">
+  <p:cSld>
+    <p:spTree>
+      <p:nvGrpSpPr>
+        <p:cNvPr id="1" name=""/>
+        <p:cNvGrpSpPr/>
+        <p:nvPr/>
+      </p:nvGrpSpPr>
+      <p:grpSpPr>
+        <a:xfrm>
+          <a:off x="0" y="0"/>
+          <a:ext cx="0" cy="0"/>
+          <a:chOff x="0" y="0"/>
+          <a:chExt cx="0" cy="0"/>
+        </a:xfrm>
+      </p:grpSpPr>
+      <p:sp>
+        <p:nvSpPr>
+          <p:cNvPr id="2" name="Slide Image Placeholder 1"/>
+          <p:cNvSpPr>
+            <a:spLocks noGrp="1"/>
+          </p:cNvSpPr>
+          <p:nvPr>
+            <p:ph type="sldImg" idx="2"/>
+          </p:nvPr>
+        </p:nvSpPr>
+        <p:spPr/>
+      </p:sp>
+      <p:sp>
+        <p:nvSpPr>
+          <p:cNvPr id="3" name="Notes Placeholder 2"/>
+          <p:cNvSpPr>
+            <a:spLocks noGrp="1"/>
+          </p:cNvSpPr>
+          <p:nvPr>
+            <p:ph type="body" idx="3" sz="quarter"/>
+          </p:nvPr>
+        </p:nvSpPr>
+        <p:spPr/>
+        <p:txBody>
+          <a:bodyPr/>
+          <a:lstStyle/>
+          <a:p>
+            <a:r>
+              <a:t>Sources: T8 ablations, T6 family test, posthoc_boundary.json (POST-HOC, descriptive).</a:t>
+            </a:r>
+          </a:p>
+        </p:txBody>
+      </p:sp>
+      <p:sp>
+        <p:nvSpPr>
+          <p:cNvPr id="4" name="Slide Number Placeholder 3"/>
+          <p:cNvSpPr>
+            <a:spLocks noGrp="1"/>
+          </p:cNvSpPr>
+          <p:nvPr>
+            <p:ph type="sldNum" idx="5" sz="quarter"/>
+          </p:nvPr>
+        </p:nvSpPr>
+        <p:spPr/>
+      </p:sp>
+    </p:spTree>
+  </p:cSld>
+  <p:clrMapOvr>
+    <a:masterClrMapping/>
+  </p:clrMapOvr>
+</p:notes>
+</file>
+
+<file path=ppt/notesSlides/notesSlide9.xml><?xml version="1.0" encoding="utf-8"?>
+<p:notes xmlns:a="http://schemas.openxmlformats.org/drawingml/2006/main" xmlns:p="http://schemas.openxmlformats.org/presentationml/2006/main" xmlns:r="http://schemas.openxmlformats.org/officeDocument/2006/relationships">
+  <p:cSld>
+    <p:spTree>
+      <p:nvGrpSpPr>
+        <p:cNvPr id="1" name=""/>
+        <p:cNvGrpSpPr/>
+        <p:nvPr/>
+      </p:nvGrpSpPr>
+      <p:grpSpPr>
+        <a:xfrm>
+          <a:off x="0" y="0"/>
+          <a:ext cx="0" cy="0"/>
+          <a:chOff x="0" y="0"/>
+          <a:chExt cx="0" cy="0"/>
+        </a:xfrm>
+      </p:grpSpPr>
+      <p:sp>
+        <p:nvSpPr>
+          <p:cNvPr id="2" name="Slide Image Placeholder 1"/>
+          <p:cNvSpPr>
+            <a:spLocks noGrp="1"/>
+          </p:cNvSpPr>
+          <p:nvPr>
+            <p:ph type="sldImg" idx="2"/>
+          </p:nvPr>
+        </p:nvSpPr>
+        <p:spPr/>
+      </p:sp>
+      <p:sp>
+        <p:nvSpPr>
+          <p:cNvPr id="3" name="Notes Placeholder 2"/>
+          <p:cNvSpPr>
+            <a:spLocks noGrp="1"/>
+          </p:cNvSpPr>
+          <p:nvPr>
+            <p:ph type="body" idx="3" sz="quarter"/>
+          </p:nvPr>
+        </p:nvSpPr>
+        <p:spPr/>
+        <p:txBody>
+          <a:bodyPr/>
+          <a:lstStyle/>
+          <a:p>
+            <a:r>
+              <a:t>research/phase5h1_exit_report.md §14-15; research/phase5h1_supervisor_update.md.</a:t>
+            </a:r>
+          </a:p>
+        </p:txBody>
+      </p:sp>
+      <p:sp>
+        <p:nvSpPr>
+          <p:cNvPr id="4" name="Slide Number Placeholder 3"/>
+          <p:cNvSpPr>
+            <a:spLocks noGrp="1"/>
+          </p:cNvSpPr>
+          <p:nvPr>
+            <p:ph type="sldNum" idx="5" sz="quarter"/>
+          </p:nvPr>
+        </p:nvSpPr>
+        <p:spPr/>
+      </p:sp>
+    </p:spTree>
   </p:cSld>
   <p:clrMapOvr>
     <a:masterClrMapping/>
@@ -5944,29 +6139,20 @@
 </file>
 
 <file path=ppt/slides/slide6.xml><?xml version="1.0" encoding="utf-8"?>
-<p:sld xmlns:a="http://schemas.openxmlformats.org/drawingml/2006/main" xmlns:r="http://schemas.openxmlformats.org/officeDocument/2006/relationships" xmlns:p="http://schemas.openxmlformats.org/presentationml/2006/main">
-  <p:cSld name="Slide 6">
+<p:sld xmlns:a="http://schemas.openxmlformats.org/drawingml/2006/main" xmlns:p="http://schemas.openxmlformats.org/presentationml/2006/main" xmlns:r="http://schemas.openxmlformats.org/officeDocument/2006/relationships">
+  <p:cSld>
     <p:spTree>
       <p:nvGrpSpPr>
         <p:cNvPr id="1" name=""/>
         <p:cNvGrpSpPr/>
         <p:nvPr/>
       </p:nvGrpSpPr>
-      <p:grpSpPr>
-        <a:xfrm>
-          <a:off x="0" y="0"/>
-          <a:ext cx="0" cy="0"/>
-          <a:chOff x="0" y="0"/>
-          <a:chExt cx="0" cy="0"/>
-        </a:xfrm>
-      </p:grpSpPr>
-      <p:sp>
-        <p:nvSpPr>
-          <p:cNvPr id="2" name="Text 0"/>
-          <p:cNvSpPr/>
-          <p:nvPr>
-            <p:ph idx="100" type="title" hasCustomPrompt="1"/>
-          </p:nvPr>
+      <p:grpSpPr/>
+      <p:sp>
+        <p:nvSpPr>
+          <p:cNvPr id="2" name="TextBox 1"/>
+          <p:cNvSpPr txBox="1"/>
+          <p:nvPr/>
         </p:nvSpPr>
         <p:spPr>
           <a:xfrm>
@@ -5977,655 +6163,995 @@
             <a:avLst/>
           </a:prstGeom>
           <a:noFill/>
-          <a:ln/>
-        </p:spPr>
-        <p:txBody>
-          <a:bodyPr wrap="square" lIns="0" tIns="0" rIns="0" bIns="0" rtlCol="0" anchor="t"/>
-          <a:lstStyle/>
-          <a:p>
-            <a:pPr algn="l" indent="0" marL="0">
-              <a:buNone/>
-            </a:pPr>
-            <a:r>
-              <a:rPr lang="en-US" sz="2800" b="1" dirty="0">
+        </p:spPr>
+        <p:txBody>
+          <a:bodyPr wrap="square">
+            <a:spAutoFit/>
+          </a:bodyPr>
+          <a:lstStyle/>
+          <a:p>
+            <a:pPr>
+              <a:spcAft>
+                <a:spcPts val="400"/>
+              </a:spcAft>
+            </a:pPr>
+            <a:r>
+              <a:rPr sz="2600" b="1">
+                <a:solidFill>
+                  <a:srgbClr val="1D2B36"/>
+                </a:solidFill>
+                <a:latin typeface="Cambria"/>
+              </a:rPr>
+              <a:t>Registered comparison: decision NARROW</a:t>
+            </a:r>
+          </a:p>
+        </p:txBody>
+      </p:sp>
+      <p:pic>
+        <p:nvPicPr>
+          <p:cNvPr id="3" name="Picture 2" descr="fig_main_comparison.png"/>
+          <p:cNvPicPr>
+            <a:picLocks noChangeAspect="1"/>
+          </p:cNvPicPr>
+          <p:nvPr/>
+        </p:nvPicPr>
+        <p:blipFill>
+          <a:blip r:embed="rId2"/>
+          <a:stretch>
+            <a:fillRect/>
+          </a:stretch>
+        </p:blipFill>
+        <p:spPr>
+          <a:xfrm>
+            <a:off x="365760" y="1051560"/>
+            <a:ext cx="5394960" cy="2053343"/>
+          </a:xfrm>
+          <a:prstGeom prst="rect">
+            <a:avLst/>
+          </a:prstGeom>
+        </p:spPr>
+      </p:pic>
+      <p:sp>
+        <p:nvSpPr>
+          <p:cNvPr id="4" name="TextBox 3"/>
+          <p:cNvSpPr txBox="1"/>
+          <p:nvPr/>
+        </p:nvSpPr>
+        <p:spPr>
+          <a:xfrm>
+            <a:off x="5897880" y="1097280"/>
+            <a:ext cx="3017520" cy="2926080"/>
+          </a:xfrm>
+          <a:prstGeom prst="rect">
+            <a:avLst/>
+          </a:prstGeom>
+          <a:noFill/>
+        </p:spPr>
+        <p:txBody>
+          <a:bodyPr wrap="square">
+            <a:spAutoFit/>
+          </a:bodyPr>
+          <a:lstStyle/>
+          <a:p>
+            <a:pPr>
+              <a:spcAft>
+                <a:spcPts val="400"/>
+              </a:spcAft>
+            </a:pPr>
+            <a:r>
+              <a:rPr sz="1100" b="1">
+                <a:solidFill>
+                  <a:srgbClr val="1D2B36"/>
+                </a:solidFill>
+                <a:latin typeface="Calibri"/>
+              </a:rPr>
+              <a:t>K1 history | heterogeneity + duration
+</a:t>
+            </a:r>
+            <a:r>
+              <a:rPr sz="1100" b="0">
+                <a:solidFill>
+                  <a:srgbClr val="1D2B36"/>
+                </a:solidFill>
+                <a:latin typeface="Calibri"/>
+              </a:rPr>
+              <a:t>+0.145 [0.135, 0.155]   </a:t>
+            </a:r>
+            <a:r>
+              <a:rPr sz="1100" b="1">
+                <a:solidFill>
+                  <a:srgbClr val="009E73"/>
+                </a:solidFill>
+                <a:latin typeface="Calibri"/>
+              </a:rPr>
+              <a:t>PASS</a:t>
+            </a:r>
+          </a:p>
+          <a:p>
+            <a:pPr>
+              <a:spcAft>
+                <a:spcPts val="400"/>
+              </a:spcAft>
+            </a:pPr>
+            <a:r>
+              <a:rPr sz="1100" b="1">
+                <a:solidFill>
+                  <a:srgbClr val="1D2B36"/>
+                </a:solidFill>
+                <a:latin typeface="Calibri"/>
+              </a:rPr>
+              <a:t>K2 history | transition model
+</a:t>
+            </a:r>
+            <a:r>
+              <a:rPr sz="1100" b="0">
+                <a:solidFill>
+                  <a:srgbClr val="1D2B36"/>
+                </a:solidFill>
+                <a:latin typeface="Calibri"/>
+              </a:rPr>
+              <a:t>+0.083 [0.076, 0.090]   </a:t>
+            </a:r>
+            <a:r>
+              <a:rPr sz="1100" b="1">
+                <a:solidFill>
+                  <a:srgbClr val="009E73"/>
+                </a:solidFill>
+                <a:latin typeface="Calibri"/>
+              </a:rPr>
+              <a:t>PASS</a:t>
+            </a:r>
+          </a:p>
+          <a:p>
+            <a:pPr>
+              <a:spcAft>
+                <a:spcPts val="400"/>
+              </a:spcAft>
+            </a:pPr>
+            <a:r>
+              <a:rPr sz="1100" b="1">
+                <a:solidFill>
+                  <a:srgbClr val="1D2B36"/>
+                </a:solidFill>
+                <a:latin typeface="Calibri"/>
+              </a:rPr>
+              <a:t>K3 practical size
+</a:t>
+            </a:r>
+            <a:r>
+              <a:rPr sz="1100" b="0">
+                <a:solidFill>
+                  <a:srgbClr val="1D2B36"/>
+                </a:solidFill>
+                <a:latin typeface="Calibri"/>
+              </a:rPr>
+              <a:t>0.070 ≥ 0.026   </a:t>
+            </a:r>
+            <a:r>
+              <a:rPr sz="1100" b="1">
+                <a:solidFill>
+                  <a:srgbClr val="009E73"/>
+                </a:solidFill>
+                <a:latin typeface="Calibri"/>
+              </a:rPr>
+              <a:t>PASS</a:t>
+            </a:r>
+          </a:p>
+          <a:p>
+            <a:pPr>
+              <a:spcAft>
+                <a:spcPts val="400"/>
+              </a:spcAft>
+            </a:pPr>
+            <a:r>
+              <a:rPr sz="1100" b="1">
+                <a:solidFill>
+                  <a:srgbClr val="1D2B36"/>
+                </a:solidFill>
+                <a:latin typeface="Calibri"/>
+              </a:rPr>
+              <a:t>K4 reproducible interactions
+</a:t>
+            </a:r>
+            <a:r>
+              <a:rPr sz="1100" b="0">
+                <a:solidFill>
+                  <a:srgbClr val="1D2B36"/>
+                </a:solidFill>
+                <a:latin typeface="Calibri"/>
+              </a:rPr>
+              <a:t>0 discoveries   </a:t>
+            </a:r>
+            <a:r>
+              <a:rPr sz="1100" b="1">
+                <a:solidFill>
+                  <a:srgbClr val="D55E00"/>
+                </a:solidFill>
+                <a:latin typeface="Calibri"/>
+              </a:rPr>
+              <a:t>FAIL</a:t>
+            </a:r>
+          </a:p>
+          <a:p>
+            <a:pPr>
+              <a:spcAft>
+                <a:spcPts val="400"/>
+              </a:spcAft>
+            </a:pPr>
+            <a:r>
+              <a:rPr sz="1100" b="1">
+                <a:solidFill>
+                  <a:srgbClr val="1D2B36"/>
+                </a:solidFill>
+                <a:latin typeface="Calibri"/>
+              </a:rPr>
+              <a:t>Families passing
+</a:t>
+            </a:r>
+            <a:r>
+              <a:rPr sz="1100" b="0">
+                <a:solidFill>
+                  <a:srgbClr val="1D2B36"/>
+                </a:solidFill>
+                <a:latin typeface="Calibri"/>
+              </a:rPr>
+              <a:t>MOTION, SPATIAL   </a:t>
+            </a:r>
+            <a:r>
+              <a:rPr sz="1100" b="1">
+                <a:solidFill>
+                  <a:srgbClr val="009E73"/>
+                </a:solidFill>
+                <a:latin typeface="Calibri"/>
+              </a:rPr>
+              <a:t>PASS</a:t>
+            </a:r>
+          </a:p>
+        </p:txBody>
+      </p:sp>
+      <p:sp>
+        <p:nvSpPr>
+          <p:cNvPr id="5" name="TextBox 4"/>
+          <p:cNvSpPr txBox="1"/>
+          <p:nvPr/>
+        </p:nvSpPr>
+        <p:spPr>
+          <a:xfrm>
+            <a:off x="5897880" y="4069080"/>
+            <a:ext cx="3017520" cy="822960"/>
+          </a:xfrm>
+          <a:prstGeom prst="rect">
+            <a:avLst/>
+          </a:prstGeom>
+          <a:noFill/>
+        </p:spPr>
+        <p:txBody>
+          <a:bodyPr wrap="square">
+            <a:spAutoFit/>
+          </a:bodyPr>
+          <a:lstStyle/>
+          <a:p>
+            <a:pPr>
+              <a:spcAft>
+                <a:spcPts val="400"/>
+              </a:spcAft>
+            </a:pPr>
+            <a:r>
+              <a:rPr sz="900" b="0">
+                <a:solidFill>
+                  <a:srgbClr val="4A5A66"/>
+                </a:solidFill>
+                <a:latin typeface="Calibri"/>
+              </a:rPr>
+              <a:t>Held-out on 84,715 events in 1535 videos; parameters frozen (commit 289319e) before evaluation. EXPLORATORY, annotations only.</a:t>
+            </a:r>
+          </a:p>
+        </p:txBody>
+      </p:sp>
+    </p:spTree>
+  </p:cSld>
+  <p:clrMapOvr>
+    <a:masterClrMapping/>
+  </p:clrMapOvr>
+</p:sld>
+</file>
+
+<file path=ppt/slides/slide7.xml><?xml version="1.0" encoding="utf-8"?>
+<p:sld xmlns:a="http://schemas.openxmlformats.org/drawingml/2006/main" xmlns:p="http://schemas.openxmlformats.org/presentationml/2006/main" xmlns:r="http://schemas.openxmlformats.org/officeDocument/2006/relationships">
+  <p:cSld>
+    <p:spTree>
+      <p:nvGrpSpPr>
+        <p:cNvPr id="1" name=""/>
+        <p:cNvGrpSpPr/>
+        <p:nvPr/>
+      </p:nvGrpSpPr>
+      <p:grpSpPr/>
+      <p:sp>
+        <p:nvSpPr>
+          <p:cNvPr id="2" name="TextBox 1"/>
+          <p:cNvSpPr txBox="1"/>
+          <p:nvPr/>
+        </p:nvSpPr>
+        <p:spPr>
+          <a:xfrm>
+            <a:off x="457200" y="320040"/>
+            <a:ext cx="8229600" cy="731520"/>
+          </a:xfrm>
+          <a:prstGeom prst="rect">
+            <a:avLst/>
+          </a:prstGeom>
+          <a:noFill/>
+        </p:spPr>
+        <p:txBody>
+          <a:bodyPr wrap="square">
+            <a:spAutoFit/>
+          </a:bodyPr>
+          <a:lstStyle/>
+          <a:p>
+            <a:pPr>
+              <a:spcAft>
+                <a:spcPts val="400"/>
+              </a:spcAft>
+            </a:pPr>
+            <a:r>
+              <a:rPr sz="2200" b="1">
+                <a:solidFill>
+                  <a:srgbClr val="1D2B36"/>
+                </a:solidFill>
+                <a:latin typeface="Cambria"/>
+              </a:rPr>
+              <a:t>Above every null; single interactions do not replicate</a:t>
+            </a:r>
+          </a:p>
+        </p:txBody>
+      </p:sp>
+      <p:pic>
+        <p:nvPicPr>
+          <p:cNvPr id="3" name="Picture 2" descr="fig_null_comparison.png"/>
+          <p:cNvPicPr>
+            <a:picLocks noChangeAspect="1"/>
+          </p:cNvPicPr>
+          <p:nvPr/>
+        </p:nvPicPr>
+        <p:blipFill>
+          <a:blip r:embed="rId2"/>
+          <a:stretch>
+            <a:fillRect/>
+          </a:stretch>
+        </p:blipFill>
+        <p:spPr>
+          <a:xfrm>
+            <a:off x="320040" y="960120"/>
+            <a:ext cx="5669280" cy="1751379"/>
+          </a:xfrm>
+          <a:prstGeom prst="rect">
+            <a:avLst/>
+          </a:prstGeom>
+        </p:spPr>
+      </p:pic>
+      <p:pic>
+        <p:nvPicPr>
+          <p:cNvPr id="4" name="Picture 3" descr="fig_k4_stability.png"/>
+          <p:cNvPicPr>
+            <a:picLocks noChangeAspect="1"/>
+          </p:cNvPicPr>
+          <p:nvPr/>
+        </p:nvPicPr>
+        <p:blipFill>
+          <a:blip r:embed="rId3"/>
+          <a:stretch>
+            <a:fillRect/>
+          </a:stretch>
+        </p:blipFill>
+        <p:spPr>
+          <a:xfrm>
+            <a:off x="320040" y="2834640"/>
+            <a:ext cx="5669280" cy="1817370"/>
+          </a:xfrm>
+          <a:prstGeom prst="rect">
+            <a:avLst/>
+          </a:prstGeom>
+        </p:spPr>
+      </p:pic>
+      <p:sp>
+        <p:nvSpPr>
+          <p:cNvPr id="5" name="TextBox 4"/>
+          <p:cNvSpPr txBox="1"/>
+          <p:nvPr/>
+        </p:nvSpPr>
+        <p:spPr>
+          <a:xfrm>
+            <a:off x="6172200" y="1188720"/>
+            <a:ext cx="2697480" cy="3474720"/>
+          </a:xfrm>
+          <a:prstGeom prst="rect">
+            <a:avLst/>
+          </a:prstGeom>
+          <a:noFill/>
+        </p:spPr>
+        <p:txBody>
+          <a:bodyPr wrap="square">
+            <a:spAutoFit/>
+          </a:bodyPr>
+          <a:lstStyle/>
+          <a:p>
+            <a:pPr>
+              <a:spcAft>
+                <a:spcPts val="400"/>
+              </a:spcAft>
+            </a:pPr>
+            <a:r>
+              <a:rPr sz="1000" b="1">
+                <a:solidFill>
+                  <a:srgbClr val="009E73"/>
+                </a:solidFill>
+                <a:latin typeface="Calibri"/>
+              </a:rPr>
+              <a:t>Positive</a:t>
+            </a:r>
+          </a:p>
+          <a:p>
+            <a:pPr>
+              <a:spcAft>
+                <a:spcPts val="400"/>
+              </a:spcAft>
+            </a:pPr>
+            <a:r>
+              <a:rPr sz="1000" b="0">
+                <a:solidFill>
+                  <a:srgbClr val="1D2B36"/>
+                </a:solidFill>
+                <a:latin typeface="Calibri"/>
+              </a:rPr>
+              <a:t>Observed gains are about 5x the largest of 38 nulls (K1 null max 0.031, K2 null max 0.017).</a:t>
+            </a:r>
+          </a:p>
+          <a:p>
+            <a:pPr>
+              <a:spcAft>
+                <a:spcPts val="400"/>
+              </a:spcAft>
+            </a:pPr>
+            <a:r>
+              <a:rPr sz="1000" b="1">
+                <a:solidFill>
+                  <a:srgbClr val="D55E00"/>
+                </a:solidFill>
+                <a:latin typeface="Calibri"/>
+              </a:rPr>
+              <a:t>Negative findings</a:t>
+            </a:r>
+          </a:p>
+          <a:p>
+            <a:pPr>
+              <a:spcAft>
+                <a:spcPts val="400"/>
+              </a:spcAft>
+            </a:pPr>
+            <a:r>
+              <a:rPr sz="1000" b="0">
+                <a:solidFill>
+                  <a:srgbClr val="1D2B36"/>
+                </a:solidFill>
+                <a:latin typeface="Calibri"/>
+              </a:rPr>
+              <a:t>K4: 0 discoveries (min FDR 0.16 &gt; 0.10).</a:t>
+            </a:r>
+          </a:p>
+          <a:p>
+            <a:pPr>
+              <a:spcAft>
+                <a:spcPts val="400"/>
+              </a:spcAft>
+            </a:pPr>
+            <a:r>
+              <a:rPr sz="1000" b="0">
+                <a:solidFill>
+                  <a:srgbClr val="1D2B36"/>
+                </a:solidFill>
+                <a:latin typeface="Calibri"/>
+              </a:rPr>
+              <a:t>Null quality: N-circ +16% events, N-jit −9.3% to −9.8%.</a:t>
+            </a:r>
+          </a:p>
+          <a:p>
+            <a:pPr>
+              <a:spcAft>
+                <a:spcPts val="400"/>
+              </a:spcAft>
+            </a:pPr>
+            <a:r>
+              <a:rPr sz="1000" b="0">
+                <a:solidFill>
+                  <a:srgbClr val="1D2B36"/>
+                </a:solidFill>
+                <a:latin typeface="Calibri"/>
+              </a:rPr>
+              <a:t>K4 statistic is inflated by ridge shrinkage in sparse cells (post-hoc).</a:t>
+            </a:r>
+          </a:p>
+        </p:txBody>
+      </p:sp>
+    </p:spTree>
+  </p:cSld>
+  <p:clrMapOvr>
+    <a:masterClrMapping/>
+  </p:clrMapOvr>
+</p:sld>
+</file>
+
+<file path=ppt/slides/slide8.xml><?xml version="1.0" encoding="utf-8"?>
+<p:sld xmlns:a="http://schemas.openxmlformats.org/drawingml/2006/main" xmlns:p="http://schemas.openxmlformats.org/presentationml/2006/main" xmlns:r="http://schemas.openxmlformats.org/officeDocument/2006/relationships">
+  <p:cSld>
+    <p:spTree>
+      <p:nvGrpSpPr>
+        <p:cNvPr id="1" name=""/>
+        <p:cNvGrpSpPr/>
+        <p:nvPr/>
+      </p:nvGrpSpPr>
+      <p:grpSpPr/>
+      <p:sp>
+        <p:nvSpPr>
+          <p:cNvPr id="2" name="TextBox 1"/>
+          <p:cNvSpPr txBox="1"/>
+          <p:nvPr/>
+        </p:nvSpPr>
+        <p:spPr>
+          <a:xfrm>
+            <a:off x="457200" y="320040"/>
+            <a:ext cx="8229600" cy="731520"/>
+          </a:xfrm>
+          <a:prstGeom prst="rect">
+            <a:avLst/>
+          </a:prstGeom>
+          <a:noFill/>
+        </p:spPr>
+        <p:txBody>
+          <a:bodyPr wrap="square">
+            <a:spAutoFit/>
+          </a:bodyPr>
+          <a:lstStyle/>
+          <a:p>
+            <a:pPr>
+              <a:spcAft>
+                <a:spcPts val="400"/>
+              </a:spcAft>
+            </a:pPr>
+            <a:r>
+              <a:rPr sz="2600" b="1">
+                <a:solidFill>
+                  <a:srgbClr val="1D2B36"/>
+                </a:solidFill>
+                <a:latin typeface="Cambria"/>
+              </a:rPr>
+              <a:t>Mechanism, and the annotation-timing caveat</a:t>
+            </a:r>
+          </a:p>
+        </p:txBody>
+      </p:sp>
+      <p:pic>
+        <p:nvPicPr>
+          <p:cNvPr id="3" name="Picture 2" descr="fig_ablation_stability.png"/>
+          <p:cNvPicPr>
+            <a:picLocks noChangeAspect="1"/>
+          </p:cNvPicPr>
+          <p:nvPr/>
+        </p:nvPicPr>
+        <p:blipFill>
+          <a:blip r:embed="rId2"/>
+          <a:stretch>
+            <a:fillRect/>
+          </a:stretch>
+        </p:blipFill>
+        <p:spPr>
+          <a:xfrm>
+            <a:off x="320040" y="1005840"/>
+            <a:ext cx="5852160" cy="2101760"/>
+          </a:xfrm>
+          <a:prstGeom prst="rect">
+            <a:avLst/>
+          </a:prstGeom>
+        </p:spPr>
+      </p:pic>
+      <p:sp>
+        <p:nvSpPr>
+          <p:cNvPr id="4" name="TextBox 3"/>
+          <p:cNvSpPr txBox="1"/>
+          <p:nvPr/>
+        </p:nvSpPr>
+        <p:spPr>
+          <a:xfrm>
+            <a:off x="6355080" y="1051560"/>
+            <a:ext cx="2560320" cy="3840480"/>
+          </a:xfrm>
+          <a:prstGeom prst="rect">
+            <a:avLst/>
+          </a:prstGeom>
+          <a:noFill/>
+        </p:spPr>
+        <p:txBody>
+          <a:bodyPr wrap="square">
+            <a:spAutoFit/>
+          </a:bodyPr>
+          <a:lstStyle/>
+          <a:p>
+            <a:pPr>
+              <a:spcAft>
+                <a:spcPts val="400"/>
+              </a:spcAft>
+            </a:pPr>
+            <a:r>
+              <a:rPr sz="1100" b="1">
+                <a:solidFill>
+                  <a:srgbClr val="1D2B36"/>
+                </a:solidFill>
+                <a:latin typeface="Calibri"/>
+              </a:rPr>
+              <a:t>Mechanism</a:t>
+            </a:r>
+          </a:p>
+          <a:p>
+            <a:pPr>
+              <a:spcAft>
+                <a:spcPts val="400"/>
+              </a:spcAft>
+            </a:pPr>
+            <a:r>
+              <a:rPr sz="1100" b="0">
+                <a:solidFill>
+                  <a:srgbClr val="1D2B36"/>
+                </a:solidFill>
+                <a:latin typeface="Calibri"/>
+              </a:rPr>
+              <a:t>'Another relation starts → this one ends': +0.048</a:t>
+            </a:r>
+          </a:p>
+          <a:p>
+            <a:pPr>
+              <a:spcAft>
+                <a:spcPts val="400"/>
+              </a:spcAft>
+            </a:pPr>
+            <a:r>
+              <a:rPr sz="1100" b="0">
+                <a:solidFill>
+                  <a:srgbClr val="1D2B36"/>
+                </a:solidFill>
+                <a:latin typeface="Calibri"/>
+              </a:rPr>
+              <a:t>Lags ≤ 2 s carry it; 2–10 s adds +0.010</a:t>
+            </a:r>
+          </a:p>
+          <a:p>
+            <a:pPr>
+              <a:spcAft>
+                <a:spcPts val="400"/>
+              </a:spcAft>
+            </a:pPr>
+            <a:r>
+              <a:rPr sz="1100" b="0">
+                <a:solidFill>
+                  <a:srgbClr val="1D2B36"/>
+                </a:solidFill>
+                <a:latin typeface="Calibri"/>
+              </a:rPr>
+              <a:t>Positive-only (classical Hawkes) is worse: -0.031</a:t>
+            </a:r>
+          </a:p>
+          <a:p>
+            <a:pPr>
+              <a:spcAft>
+                <a:spcPts val="400"/>
+              </a:spcAft>
+            </a:pPr>
+            <a:r>
+              <a:rPr sz="1100" b="1">
+                <a:solidFill>
+                  <a:srgbClr val="D55E00"/>
+                </a:solidFill>
+                <a:latin typeface="Calibri"/>
+              </a:rPr>
+              <a:t>Caveat</a:t>
+            </a:r>
+          </a:p>
+          <a:p>
+            <a:pPr>
+              <a:spcAft>
+                <a:spcPts val="400"/>
+              </a:spcAft>
+            </a:pPr>
+            <a:r>
+              <a:rPr sz="1100" b="0">
+                <a:solidFill>
+                  <a:srgbClr val="1D2B36"/>
+                </a:solidFill>
+                <a:latin typeface="Calibri"/>
+              </a:rPr>
+              <a:t>17.0% of events tie exactly with another relation's boundary on the same pair (spatial relabelling). Predictive association in annotation timing — not causal, not real video.</a:t>
+            </a:r>
+          </a:p>
+        </p:txBody>
+      </p:sp>
+    </p:spTree>
+  </p:cSld>
+  <p:clrMapOvr>
+    <a:masterClrMapping/>
+  </p:clrMapOvr>
+</p:sld>
+</file>
+
+<file path=ppt/slides/slide9.xml><?xml version="1.0" encoding="utf-8"?>
+<p:sld xmlns:a="http://schemas.openxmlformats.org/drawingml/2006/main" xmlns:p="http://schemas.openxmlformats.org/presentationml/2006/main" xmlns:r="http://schemas.openxmlformats.org/officeDocument/2006/relationships">
+  <p:cSld>
+    <p:spTree>
+      <p:nvGrpSpPr>
+        <p:cNvPr id="1" name=""/>
+        <p:cNvGrpSpPr/>
+        <p:nvPr/>
+      </p:nvGrpSpPr>
+      <p:grpSpPr/>
+      <p:sp>
+        <p:nvSpPr>
+          <p:cNvPr id="2" name="TextBox 1"/>
+          <p:cNvSpPr txBox="1"/>
+          <p:nvPr/>
+        </p:nvSpPr>
+        <p:spPr>
+          <a:xfrm>
+            <a:off x="457200" y="320040"/>
+            <a:ext cx="8229600" cy="731520"/>
+          </a:xfrm>
+          <a:prstGeom prst="rect">
+            <a:avLst/>
+          </a:prstGeom>
+          <a:noFill/>
+        </p:spPr>
+        <p:txBody>
+          <a:bodyPr wrap="square">
+            <a:spAutoFit/>
+          </a:bodyPr>
+          <a:lstStyle/>
+          <a:p>
+            <a:pPr>
+              <a:spcAft>
+                <a:spcPts val="400"/>
+              </a:spcAft>
+            </a:pPr>
+            <a:r>
+              <a:rPr sz="2600" b="1">
                 <a:solidFill>
                   <a:srgbClr val="FFFFFF"/>
                 </a:solidFill>
-                <a:latin typeface="Cambria" pitchFamily="34" charset="0"/>
-                <a:ea typeface="Cambria" pitchFamily="34" charset="-122"/>
-                <a:cs typeface="Cambria" pitchFamily="34" charset="-120"/>
-              </a:rPr>
-              <a:t>Next experiment and decision gate</a:t>
-            </a:r>
-            <a:endParaRPr lang="en-US" sz="2800" dirty="0"/>
-          </a:p>
-        </p:txBody>
-      </p:sp>
-      <p:sp>
-        <p:nvSpPr>
-          <p:cNvPr id="3" name="Text 1"/>
-          <p:cNvSpPr txBox="1"/>
-          <p:nvPr/>
-        </p:nvSpPr>
-        <p:spPr>
-          <a:xfrm>
-            <a:off x="457200" y="1188720"/>
-            <a:ext cx="3931920" cy="320040"/>
-          </a:xfrm>
-          <a:prstGeom prst="rect">
-            <a:avLst/>
-          </a:prstGeom>
-          <a:noFill/>
-          <a:ln/>
-        </p:spPr>
-        <p:txBody>
-          <a:bodyPr wrap="square" lIns="0" tIns="0" rIns="0" bIns="0" rtlCol="0" anchor="ctr"/>
-          <a:lstStyle/>
-          <a:p>
-            <a:pPr indent="0" marL="0">
-              <a:buNone/>
-            </a:pPr>
-            <a:r>
-              <a:rPr lang="en-US" sz="1500" b="1" dirty="0">
+                <a:latin typeface="Cambria"/>
+              </a:rPr>
+              <a:t>Decision and next step</a:t>
+            </a:r>
+          </a:p>
+        </p:txBody>
+      </p:sp>
+      <p:sp>
+        <p:nvSpPr>
+          <p:cNvPr id="3" name="TextBox 2"/>
+          <p:cNvSpPr txBox="1"/>
+          <p:nvPr/>
+        </p:nvSpPr>
+        <p:spPr>
+          <a:xfrm>
+            <a:off x="457200" y="1143000"/>
+            <a:ext cx="5120640" cy="3291840"/>
+          </a:xfrm>
+          <a:prstGeom prst="rect">
+            <a:avLst/>
+          </a:prstGeom>
+          <a:noFill/>
+        </p:spPr>
+        <p:txBody>
+          <a:bodyPr wrap="square">
+            <a:spAutoFit/>
+          </a:bodyPr>
+          <a:lstStyle/>
+          <a:p>
+            <a:pPr>
+              <a:spcAft>
+                <a:spcPts val="400"/>
+              </a:spcAft>
+            </a:pPr>
+            <a:r>
+              <a:rPr sz="1600" b="1">
                 <a:solidFill>
                   <a:srgbClr val="F2B48C"/>
                 </a:solidFill>
-                <a:latin typeface="Calibri" pitchFamily="34" charset="0"/>
-                <a:ea typeface="Calibri" pitchFamily="34" charset="-122"/>
-                <a:cs typeface="Calibri" pitchFamily="34" charset="-120"/>
-              </a:rPr>
-              <a:t>Next run (registered, exploratory)</a:t>
-            </a:r>
-            <a:endParaRPr lang="en-US" sz="1500" dirty="0"/>
-          </a:p>
-        </p:txBody>
-      </p:sp>
-      <p:sp>
-        <p:nvSpPr>
-          <p:cNvPr id="4" name="Text 2"/>
-          <p:cNvSpPr txBox="1"/>
-          <p:nvPr/>
-        </p:nvSpPr>
-        <p:spPr>
-          <a:xfrm>
-            <a:off x="457200" y="1572768"/>
-            <a:ext cx="3931920" cy="2377440"/>
-          </a:xfrm>
-          <a:prstGeom prst="rect">
-            <a:avLst/>
-          </a:prstGeom>
-          <a:noFill/>
-          <a:ln/>
-        </p:spPr>
-        <p:txBody>
-          <a:bodyPr wrap="square" lIns="0" tIns="0" rIns="0" bIns="0" rtlCol="0" anchor="t"/>
-          <a:lstStyle/>
-          <a:p>
-            <a:pPr marL="342900" indent="-342900">
+                <a:latin typeface="Calibri"/>
+              </a:rPr>
+              <a:t>NARROW: </a:t>
+            </a:r>
+            <a:r>
+              <a:rPr sz="1500" b="0">
+                <a:solidFill>
+                  <a:srgbClr val="FFFFFF"/>
+                </a:solidFill>
+                <a:latin typeface="Calibri"/>
+              </a:rPr>
+              <a:t>a real, consistent predictive gain from cross-relation timing in VidOR annotations, mainly spatial and motion relabelling within 2 s.</a:t>
+            </a:r>
+          </a:p>
+          <a:p>
+            <a:pPr>
               <a:spcAft>
-                <a:spcPts val="600"/>
+                <a:spcPts val="400"/>
               </a:spcAft>
-              <a:buSzPct val="100000"/>
-              <a:buChar char="•"/>
-            </a:pPr>
-            <a:r>
-              <a:rPr lang="en-US" sz="1400" dirty="0">
+            </a:pPr>
+            <a:r>
+              <a:rPr sz="1400" b="1">
+                <a:solidFill>
+                  <a:srgbClr val="F2B48C"/>
+                </a:solidFill>
+                <a:latin typeface="Calibri"/>
+              </a:rPr>
+              <a:t>No method contribution: </a:t>
+            </a:r>
+            <a:r>
+              <a:rPr sz="1400" b="0">
                 <a:solidFill>
                   <a:srgbClr val="FFFFFF"/>
                 </a:solidFill>
-                <a:latin typeface="Calibri" pitchFamily="34" charset="0"/>
-                <a:ea typeface="Calibri" pitchFamily="34" charset="-122"/>
-                <a:cs typeface="Calibri" pitchFamily="34" charset="-120"/>
-              </a:rPr>
-              <a:t>Fit G0–G4 on 5,600 training videos; choose penalty on 700 selection videos</a:t>
-            </a:r>
-            <a:endParaRPr lang="en-US" sz="1400" dirty="0"/>
-          </a:p>
-          <a:p>
-            <a:pPr marL="342900" indent="-342900">
+                <a:latin typeface="Calibri"/>
+              </a:rPr>
+              <a:t>standard GLM; classical Hawkes is the worse variant; no reproducible interaction.</a:t>
+            </a:r>
+          </a:p>
+          <a:p>
+            <a:pPr>
               <a:spcAft>
-                <a:spcPts val="600"/>
+                <a:spcPts val="400"/>
               </a:spcAft>
-              <a:buSzPct val="100000"/>
-              <a:buChar char="•"/>
-            </a:pPr>
-            <a:r>
-              <a:rPr lang="en-US" sz="1400" dirty="0">
+            </a:pPr>
+            <a:r>
+              <a:rPr sz="1400" b="1">
+                <a:solidFill>
+                  <a:srgbClr val="F2B48C"/>
+                </a:solidFill>
+                <a:latin typeface="Calibri"/>
+              </a:rPr>
+              <a:t>Main paper track: </a:t>
+            </a:r>
+            <a:r>
+              <a:rPr sz="1400" b="0">
                 <a:solidFill>
                   <a:srgbClr val="FFFFFF"/>
                 </a:solidFill>
-                <a:latin typeface="Calibri" pitchFamily="34" charset="0"/>
-                <a:ea typeface="Calibri" pitchFamily="34" charset="-122"/>
-                <a:cs typeface="Calibri" pitchFamily="34" charset="-120"/>
-              </a:rPr>
-              <a:t>Evaluate on 1,535 held-out videos (previously used only in aggregate)</a:t>
-            </a:r>
-            <a:endParaRPr lang="en-US" sz="1400" dirty="0"/>
-          </a:p>
-          <a:p>
-            <a:pPr marL="342900" indent="-342900">
+                <a:latin typeface="Calibri"/>
+              </a:rPr>
+              <a:t>robustness/evaluation paper (Phases 3–4); this as an exploratory section.</a:t>
+            </a:r>
+          </a:p>
+        </p:txBody>
+      </p:sp>
+      <p:sp>
+        <p:nvSpPr>
+          <p:cNvPr id="4" name="TextBox 3"/>
+          <p:cNvSpPr txBox="1"/>
+          <p:nvPr/>
+        </p:nvSpPr>
+        <p:spPr>
+          <a:xfrm>
+            <a:off x="5852160" y="1143000"/>
+            <a:ext cx="2926080" cy="3291840"/>
+          </a:xfrm>
+          <a:prstGeom prst="rect">
+            <a:avLst/>
+          </a:prstGeom>
+          <a:noFill/>
+        </p:spPr>
+        <p:txBody>
+          <a:bodyPr wrap="square">
+            <a:spAutoFit/>
+          </a:bodyPr>
+          <a:lstStyle/>
+          <a:p>
+            <a:pPr>
               <a:spcAft>
-                <a:spcPts val="600"/>
+                <a:spcPts val="400"/>
               </a:spcAft>
-              <a:buSzPct val="100000"/>
-              <a:buChar char="•"/>
-            </a:pPr>
-            <a:r>
-              <a:rPr lang="en-US" sz="1400" dirty="0">
+            </a:pPr>
+            <a:r>
+              <a:rPr sz="1100" b="1">
+                <a:solidFill>
+                  <a:srgbClr val="F2B48C"/>
+                </a:solidFill>
+                <a:latin typeface="Calibri"/>
+              </a:rPr>
+              <a:t>Proposed, not started</a:t>
+            </a:r>
+          </a:p>
+          <a:p>
+            <a:pPr>
+              <a:spcAft>
+                <a:spcPts val="400"/>
+              </a:spcAft>
+            </a:pPr>
+            <a:r>
+              <a:rPr sz="1100" b="0">
                 <a:solidFill>
                   <a:srgbClr val="FFFFFF"/>
                 </a:solidFill>
-                <a:latin typeface="Calibri" pitchFamily="34" charset="0"/>
-                <a:ea typeface="Calibri" pitchFamily="34" charset="-122"/>
-                <a:cs typeface="Calibri" pitchFamily="34" charset="-120"/>
-              </a:rPr>
-              <a:t>Two nulls × 19 runs; 5-fold stability; test 4 Stage 0 hypotheses</a:t>
-            </a:r>
-            <a:endParaRPr lang="en-US" sz="1400" dirty="0"/>
-          </a:p>
-          <a:p>
-            <a:pPr marL="342900" indent="-342900">
+                <a:latin typeface="Calibri"/>
+              </a:rPr>
+              <a:t>Independent confirmation (VidVRD or PVSG), pre-registered first:</a:t>
+            </a:r>
+          </a:p>
+          <a:p>
+            <a:pPr>
               <a:spcAft>
-                <a:spcPts val="600"/>
+                <a:spcPts val="400"/>
               </a:spcAft>
-              <a:buSzPct val="100000"/>
-              <a:buChar char="•"/>
-            </a:pPr>
-            <a:r>
-              <a:rPr lang="en-US" sz="1400" dirty="0">
+            </a:pPr>
+            <a:r>
+              <a:rPr sz="1100" b="0">
                 <a:solidFill>
                   <a:srgbClr val="FFFFFF"/>
                 </a:solidFill>
-                <a:latin typeface="Calibri" pitchFamily="34" charset="0"/>
-                <a:ea typeface="Calibri" pitchFamily="34" charset="-122"/>
-                <a:cs typeface="Calibri" pitchFamily="34" charset="-120"/>
-              </a:rPr>
-              <a:t>Needs parallel fitting: estimated 30–60 single-thread CPU-hours</a:t>
-            </a:r>
-            <a:endParaRPr lang="en-US" sz="1400" dirty="0"/>
-          </a:p>
-        </p:txBody>
-      </p:sp>
-      <p:sp>
-        <p:nvSpPr>
-          <p:cNvPr id="5" name="Shape 3"/>
-          <p:cNvSpPr/>
-          <p:nvPr/>
-        </p:nvSpPr>
-        <p:spPr>
-          <a:xfrm>
-            <a:off x="4754880" y="1234440"/>
-            <a:ext cx="3931920" cy="868680"/>
-          </a:xfrm>
-          <a:prstGeom prst="roundRect">
-            <a:avLst>
-              <a:gd name="adj" fmla="val 8421"/>
-            </a:avLst>
-          </a:prstGeom>
-          <a:solidFill>
-            <a:srgbClr val="26394A"/>
-          </a:solidFill>
-          <a:ln w="12700">
-            <a:solidFill>
-              <a:srgbClr val="26394A"/>
-            </a:solidFill>
-            <a:prstDash val="solid"/>
-          </a:ln>
-        </p:spPr>
-      </p:sp>
-      <p:sp>
-        <p:nvSpPr>
-          <p:cNvPr id="6" name="Shape 4"/>
-          <p:cNvSpPr/>
-          <p:nvPr/>
-        </p:nvSpPr>
-        <p:spPr>
-          <a:xfrm>
-            <a:off x="4864608" y="1417320"/>
-            <a:ext cx="1051560" cy="502920"/>
-          </a:xfrm>
-          <a:prstGeom prst="roundRect">
-            <a:avLst>
-              <a:gd name="adj" fmla="val 14545"/>
-            </a:avLst>
-          </a:prstGeom>
-          <a:solidFill>
-            <a:srgbClr val="009E73"/>
-          </a:solidFill>
-          <a:ln w="12700">
-            <a:solidFill>
-              <a:srgbClr val="009E73"/>
-            </a:solidFill>
-            <a:prstDash val="solid"/>
-          </a:ln>
-        </p:spPr>
-      </p:sp>
-      <p:sp>
-        <p:nvSpPr>
-          <p:cNvPr id="7" name="Text 5"/>
-          <p:cNvSpPr txBox="1"/>
-          <p:nvPr/>
-        </p:nvSpPr>
-        <p:spPr>
-          <a:xfrm>
-            <a:off x="4864608" y="1417320"/>
-            <a:ext cx="1051560" cy="502920"/>
-          </a:xfrm>
-          <a:prstGeom prst="rect">
-            <a:avLst/>
-          </a:prstGeom>
-          <a:noFill/>
-          <a:ln/>
-        </p:spPr>
-        <p:txBody>
-          <a:bodyPr wrap="square" lIns="0" tIns="0" rIns="0" bIns="0" rtlCol="0" anchor="ctr"/>
-          <a:lstStyle/>
-          <a:p>
-            <a:pPr algn="ctr" indent="0" marL="0">
-              <a:buNone/>
-            </a:pPr>
-            <a:r>
-              <a:rPr lang="en-US" sz="1500" b="1" dirty="0">
+                <a:latin typeface="Calibri"/>
+              </a:rPr>
+              <a:t>• repaired nulls (reflection jitter, boundary-tie control)</a:t>
+            </a:r>
+          </a:p>
+          <a:p>
+            <a:pPr>
+              <a:spcAft>
+                <a:spcPts val="400"/>
+              </a:spcAft>
+            </a:pPr>
+            <a:r>
+              <a:rPr sz="1100" b="0">
                 <a:solidFill>
                   <a:srgbClr val="FFFFFF"/>
                 </a:solidFill>
-                <a:latin typeface="Calibri" pitchFamily="34" charset="0"/>
-                <a:ea typeface="Calibri" pitchFamily="34" charset="-122"/>
-                <a:cs typeface="Calibri" pitchFamily="34" charset="-120"/>
-              </a:rPr>
-              <a:t>GO</a:t>
-            </a:r>
-            <a:endParaRPr lang="en-US" sz="1500" dirty="0"/>
-          </a:p>
-        </p:txBody>
-      </p:sp>
-      <p:sp>
-        <p:nvSpPr>
-          <p:cNvPr id="8" name="Text 6"/>
-          <p:cNvSpPr txBox="1"/>
-          <p:nvPr/>
-        </p:nvSpPr>
-        <p:spPr>
-          <a:xfrm>
-            <a:off x="6035040" y="1325880"/>
-            <a:ext cx="2560320" cy="685800"/>
-          </a:xfrm>
-          <a:prstGeom prst="rect">
-            <a:avLst/>
-          </a:prstGeom>
-          <a:noFill/>
-          <a:ln/>
-        </p:spPr>
-        <p:txBody>
-          <a:bodyPr wrap="square" lIns="0" tIns="0" rIns="0" bIns="0" rtlCol="0" anchor="ctr"/>
-          <a:lstStyle/>
-          <a:p>
-            <a:pPr indent="0" marL="0">
-              <a:buNone/>
-            </a:pPr>
-            <a:r>
-              <a:rPr lang="en-US" sz="1300" dirty="0">
+                <a:latin typeface="Calibri"/>
+              </a:rPr>
+              <a:t>• support-aware stability statistic</a:t>
+            </a:r>
+          </a:p>
+          <a:p>
+            <a:pPr>
+              <a:spcAft>
+                <a:spcPts val="400"/>
+              </a:spcAft>
+            </a:pPr>
+            <a:r>
+              <a:rPr sz="1100" b="0">
                 <a:solidFill>
                   <a:srgbClr val="FFFFFF"/>
                 </a:solidFill>
-                <a:latin typeface="Calibri" pitchFamily="34" charset="0"/>
-                <a:ea typeface="Calibri" pitchFamily="34" charset="-122"/>
-                <a:cs typeface="Calibri" pitchFamily="34" charset="-120"/>
-              </a:rPr>
-              <a:t>All 4 criteria pass → confirm on an independent dataset</a:t>
-            </a:r>
-            <a:endParaRPr lang="en-US" sz="1300" dirty="0"/>
-          </a:p>
-        </p:txBody>
-      </p:sp>
-      <p:sp>
-        <p:nvSpPr>
-          <p:cNvPr id="9" name="Shape 7"/>
-          <p:cNvSpPr/>
-          <p:nvPr/>
-        </p:nvSpPr>
-        <p:spPr>
-          <a:xfrm>
-            <a:off x="4754880" y="2258568"/>
-            <a:ext cx="3931920" cy="868680"/>
-          </a:xfrm>
-          <a:prstGeom prst="roundRect">
-            <a:avLst>
-              <a:gd name="adj" fmla="val 8421"/>
-            </a:avLst>
-          </a:prstGeom>
-          <a:solidFill>
-            <a:srgbClr val="26394A"/>
-          </a:solidFill>
-          <a:ln w="12700">
-            <a:solidFill>
-              <a:srgbClr val="26394A"/>
-            </a:solidFill>
-            <a:prstDash val="solid"/>
-          </a:ln>
-        </p:spPr>
-      </p:sp>
-      <p:sp>
-        <p:nvSpPr>
-          <p:cNvPr id="10" name="Shape 8"/>
-          <p:cNvSpPr/>
-          <p:nvPr/>
-        </p:nvSpPr>
-        <p:spPr>
-          <a:xfrm>
-            <a:off x="4864608" y="2441448"/>
-            <a:ext cx="1051560" cy="502920"/>
-          </a:xfrm>
-          <a:prstGeom prst="roundRect">
-            <a:avLst>
-              <a:gd name="adj" fmla="val 14545"/>
-            </a:avLst>
-          </a:prstGeom>
-          <a:solidFill>
-            <a:srgbClr val="E69F00"/>
-          </a:solidFill>
-          <a:ln w="12700">
-            <a:solidFill>
-              <a:srgbClr val="E69F00"/>
-            </a:solidFill>
-            <a:prstDash val="solid"/>
-          </a:ln>
-        </p:spPr>
-      </p:sp>
-      <p:sp>
-        <p:nvSpPr>
-          <p:cNvPr id="11" name="Text 9"/>
-          <p:cNvSpPr txBox="1"/>
-          <p:nvPr/>
-        </p:nvSpPr>
-        <p:spPr>
-          <a:xfrm>
-            <a:off x="4864608" y="2441448"/>
-            <a:ext cx="1051560" cy="502920"/>
-          </a:xfrm>
-          <a:prstGeom prst="rect">
-            <a:avLst/>
-          </a:prstGeom>
-          <a:noFill/>
-          <a:ln/>
-        </p:spPr>
-        <p:txBody>
-          <a:bodyPr wrap="square" lIns="0" tIns="0" rIns="0" bIns="0" rtlCol="0" anchor="ctr"/>
-          <a:lstStyle/>
-          <a:p>
-            <a:pPr algn="ctr" indent="0" marL="0">
-              <a:buNone/>
-            </a:pPr>
-            <a:r>
-              <a:rPr lang="en-US" sz="1500" b="1" dirty="0">
-                <a:solidFill>
-                  <a:srgbClr val="FFFFFF"/>
-                </a:solidFill>
-                <a:latin typeface="Calibri" pitchFamily="34" charset="0"/>
-                <a:ea typeface="Calibri" pitchFamily="34" charset="-122"/>
-                <a:cs typeface="Calibri" pitchFamily="34" charset="-120"/>
-              </a:rPr>
-              <a:t>NARROW</a:t>
-            </a:r>
-            <a:endParaRPr lang="en-US" sz="1500" dirty="0"/>
-          </a:p>
-        </p:txBody>
-      </p:sp>
-      <p:sp>
-        <p:nvSpPr>
-          <p:cNvPr id="12" name="Text 10"/>
-          <p:cNvSpPr txBox="1"/>
-          <p:nvPr/>
-        </p:nvSpPr>
-        <p:spPr>
-          <a:xfrm>
-            <a:off x="6035040" y="2350008"/>
-            <a:ext cx="2560320" cy="685800"/>
-          </a:xfrm>
-          <a:prstGeom prst="rect">
-            <a:avLst/>
-          </a:prstGeom>
-          <a:noFill/>
-          <a:ln/>
-        </p:spPr>
-        <p:txBody>
-          <a:bodyPr wrap="square" lIns="0" tIns="0" rIns="0" bIns="0" rtlCol="0" anchor="ctr"/>
-          <a:lstStyle/>
-          <a:p>
-            <a:pPr indent="0" marL="0">
-              <a:buNone/>
-            </a:pPr>
-            <a:r>
-              <a:rPr lang="en-US" sz="1300" dirty="0">
-                <a:solidFill>
-                  <a:srgbClr val="FFFFFF"/>
-                </a:solidFill>
-                <a:latin typeface="Calibri" pitchFamily="34" charset="0"/>
-                <a:ea typeface="Calibri" pitchFamily="34" charset="-122"/>
-                <a:cs typeface="Calibri" pitchFamily="34" charset="-120"/>
-              </a:rPr>
-              <a:t>Signal only in specific relation families → restrict claims</a:t>
-            </a:r>
-            <a:endParaRPr lang="en-US" sz="1300" dirty="0"/>
-          </a:p>
-        </p:txBody>
-      </p:sp>
-      <p:sp>
-        <p:nvSpPr>
-          <p:cNvPr id="13" name="Shape 11"/>
-          <p:cNvSpPr/>
-          <p:nvPr/>
-        </p:nvSpPr>
-        <p:spPr>
-          <a:xfrm>
-            <a:off x="4754880" y="3282696"/>
-            <a:ext cx="3931920" cy="868680"/>
-          </a:xfrm>
-          <a:prstGeom prst="roundRect">
-            <a:avLst>
-              <a:gd name="adj" fmla="val 8421"/>
-            </a:avLst>
-          </a:prstGeom>
-          <a:solidFill>
-            <a:srgbClr val="26394A"/>
-          </a:solidFill>
-          <a:ln w="12700">
-            <a:solidFill>
-              <a:srgbClr val="26394A"/>
-            </a:solidFill>
-            <a:prstDash val="solid"/>
-          </a:ln>
-        </p:spPr>
-      </p:sp>
-      <p:sp>
-        <p:nvSpPr>
-          <p:cNvPr id="14" name="Shape 12"/>
-          <p:cNvSpPr/>
-          <p:nvPr/>
-        </p:nvSpPr>
-        <p:spPr>
-          <a:xfrm>
-            <a:off x="4864608" y="3465576"/>
-            <a:ext cx="1051560" cy="502920"/>
-          </a:xfrm>
-          <a:prstGeom prst="roundRect">
-            <a:avLst>
-              <a:gd name="adj" fmla="val 14545"/>
-            </a:avLst>
-          </a:prstGeom>
-          <a:solidFill>
-            <a:srgbClr val="D55E00"/>
-          </a:solidFill>
-          <a:ln w="12700">
-            <a:solidFill>
-              <a:srgbClr val="D55E00"/>
-            </a:solidFill>
-            <a:prstDash val="solid"/>
-          </a:ln>
-        </p:spPr>
-      </p:sp>
-      <p:sp>
-        <p:nvSpPr>
-          <p:cNvPr id="15" name="Text 13"/>
-          <p:cNvSpPr txBox="1"/>
-          <p:nvPr/>
-        </p:nvSpPr>
-        <p:spPr>
-          <a:xfrm>
-            <a:off x="4864608" y="3465576"/>
-            <a:ext cx="1051560" cy="502920"/>
-          </a:xfrm>
-          <a:prstGeom prst="rect">
-            <a:avLst/>
-          </a:prstGeom>
-          <a:noFill/>
-          <a:ln/>
-        </p:spPr>
-        <p:txBody>
-          <a:bodyPr wrap="square" lIns="0" tIns="0" rIns="0" bIns="0" rtlCol="0" anchor="ctr"/>
-          <a:lstStyle/>
-          <a:p>
-            <a:pPr algn="ctr" indent="0" marL="0">
-              <a:buNone/>
-            </a:pPr>
-            <a:r>
-              <a:rPr lang="en-US" sz="1500" b="1" dirty="0">
-                <a:solidFill>
-                  <a:srgbClr val="FFFFFF"/>
-                </a:solidFill>
-                <a:latin typeface="Calibri" pitchFamily="34" charset="0"/>
-                <a:ea typeface="Calibri" pitchFamily="34" charset="-122"/>
-                <a:cs typeface="Calibri" pitchFamily="34" charset="-120"/>
-              </a:rPr>
-              <a:t>STOP</a:t>
-            </a:r>
-            <a:endParaRPr lang="en-US" sz="1500" dirty="0"/>
-          </a:p>
-        </p:txBody>
-      </p:sp>
-      <p:sp>
-        <p:nvSpPr>
-          <p:cNvPr id="16" name="Text 14"/>
-          <p:cNvSpPr txBox="1"/>
-          <p:nvPr/>
-        </p:nvSpPr>
-        <p:spPr>
-          <a:xfrm>
-            <a:off x="6035040" y="3374136"/>
-            <a:ext cx="2560320" cy="685800"/>
-          </a:xfrm>
-          <a:prstGeom prst="rect">
-            <a:avLst/>
-          </a:prstGeom>
-          <a:noFill/>
-          <a:ln/>
-        </p:spPr>
-        <p:txBody>
-          <a:bodyPr wrap="square" lIns="0" tIns="0" rIns="0" bIns="0" rtlCol="0" anchor="ctr"/>
-          <a:lstStyle/>
-          <a:p>
-            <a:pPr indent="0" marL="0">
-              <a:buNone/>
-            </a:pPr>
-            <a:r>
-              <a:rPr lang="en-US" sz="1300" dirty="0">
-                <a:solidFill>
-                  <a:srgbClr val="FFFFFF"/>
-                </a:solidFill>
-                <a:latin typeface="Calibri" pitchFamily="34" charset="0"/>
-                <a:ea typeface="Calibri" pitchFamily="34" charset="-122"/>
-                <a:cs typeface="Calibri" pitchFamily="34" charset="-120"/>
-              </a:rPr>
-              <a:t>Simple models explain it → drop Hawkes; evaluation paper remains</a:t>
-            </a:r>
-            <a:endParaRPr lang="en-US" sz="1300" dirty="0"/>
-          </a:p>
-        </p:txBody>
-      </p:sp>
-      <p:sp>
-        <p:nvSpPr>
-          <p:cNvPr id="17" name="Text 15"/>
-          <p:cNvSpPr txBox="1"/>
-          <p:nvPr/>
-        </p:nvSpPr>
-        <p:spPr>
-          <a:xfrm>
-            <a:off x="457200" y="4343400"/>
-            <a:ext cx="8229600" cy="365760"/>
-          </a:xfrm>
-          <a:prstGeom prst="rect">
-            <a:avLst/>
-          </a:prstGeom>
-          <a:noFill/>
-          <a:ln/>
-        </p:spPr>
-        <p:txBody>
-          <a:bodyPr wrap="square" lIns="0" tIns="0" rIns="0" bIns="0" rtlCol="0" anchor="ctr"/>
-          <a:lstStyle/>
-          <a:p>
-            <a:pPr indent="0" marL="0">
-              <a:buNone/>
-            </a:pPr>
-            <a:r>
-              <a:rPr lang="en-US" sz="1400" b="1" dirty="0">
+                <a:latin typeface="Calibri"/>
+              </a:rPr>
+              <a:t>• directional hypotheses fixed from this report</a:t>
+            </a:r>
+          </a:p>
+          <a:p>
+            <a:pPr>
+              <a:spcAft>
+                <a:spcPts val="400"/>
+              </a:spcAft>
+            </a:pPr>
+            <a:r>
+              <a:rPr sz="1100" b="1">
                 <a:solidFill>
                   <a:srgbClr val="F2B48C"/>
                 </a:solidFill>
-                <a:latin typeface="Calibri" pitchFamily="34" charset="0"/>
-                <a:ea typeface="Calibri" pitchFamily="34" charset="-122"/>
-                <a:cs typeface="Calibri" pitchFamily="34" charset="-120"/>
-              </a:rPr>
-              <a:t>Decision needed: approve compute for the full run, and an independent annotated dataset for confirmation.</a:t>
-            </a:r>
-            <a:endParaRPr lang="en-US" sz="1400" dirty="0"/>
-          </a:p>
-        </p:txBody>
-      </p:sp>
-      <p:sp>
-        <p:nvSpPr>
-          <p:cNvPr id="25" name="Slide Number Placeholder 0"/>
-          <p:cNvSpPr>
-            <a:spLocks noGrp="1"/>
-          </p:cNvSpPr>
-          <p:nvPr>
-            <p:ph type="sldNum" sz="quarter" idx="4294967295"/>
-          </p:nvPr>
-        </p:nvSpPr>
-        <p:spPr>
-          <a:xfrm>
-            <a:off x="8412480" y="4754880"/>
-            <a:ext cx="365760" cy="274320"/>
-          </a:xfrm>
-          <a:prstGeom prst="rect">
-            <a:avLst/>
-          </a:prstGeom>
-          <a:extLst>
-            <a:ext uri="{C572A759-6A51-4108-AA02-DFA0A04FC94B}">
-              <ma14:wrappingTextBoxFlag xmlns:ma14="http://schemas.microsoft.com/office/mac/drawingml/2011/main" val="0"/>
-            </a:ext>
-          </a:extLst>
-        </p:spPr>
-        <p:txBody>
-          <a:bodyPr/>
-          <a:lstStyle>
-            <a:lvl1pPr>
-              <a:defRPr sz="1000">
-                <a:solidFill>
-                  <a:srgbClr val="9AA7B0"/>
-                </a:solidFill>
                 <a:latin typeface="Calibri"/>
-                <a:ea typeface="Calibri"/>
-                <a:cs typeface="Calibri"/>
-              </a:defRPr>
-            </a:lvl1pPr>
-          </a:lstStyle>
-          <a:p>
-            <a:pPr algn="l"/>
-            <a:fld id="{F7021451-1387-4CA6-816F-3879F97B5CBC}" type="slidenum">
-              <a:rPr b="0" lang="en-US"/>
-              <a:t>6</a:t>
-            </a:fld>
-            <a:endParaRPr lang="en-US"/>
+              </a:rPr>
+              <a:t>Demo ≠ evidence: </a:t>
+            </a:r>
+            <a:r>
+              <a:rPr sz="1100" b="0">
+                <a:solidFill>
+                  <a:srgbClr val="C9D3DA"/>
+                </a:solidFill>
+                <a:latin typeface="Calibri"/>
+              </a:rPr>
+              <a:t>the video demo is a synthetic illustration with hand-picked settings.</a:t>
+            </a:r>
           </a:p>
         </p:txBody>
       </p:sp>

</xml_diff>